<commit_message>
Replace the Regan et al. slide with a simple engine-scale slide
Two short quotes (Guid and Bratko 2011; Regan et al. 2014) showing that
centipawn scores depend on the program and depth, and why that means our
ACPL cannot be compared with other papers' but our group comparison is
fair. Adds Guid and Bratko (2011) to the references.

Co-Authored-By: Claude Opus 5.5 <noreply@anthropic.com>
Claude-Session: https://claude.ai/code/session_01M9V7nrLidvW1xnBrcuESwN
</commit_message>
<xml_diff>
--- a/slides/study2-final.pptx
+++ b/slides/study2-final.pptx
@@ -148,12 +148,12 @@
   <p:extLst>
     <p:ext uri="{521415D9-36F7-43E2-AB2F-B90AF26B5E84}">
       <p14:sectionLst xmlns:p14="http://schemas.microsoft.com/office/powerpoint/2010/main">
-        <p14:section name="Introduction" id="{c7b899e5-c9f2-f6b0-d009-dc62bf0770cd}">
+        <p14:section name="Introduction" id="{b46a9ef9-1fc2-3693-986b-f98469625dc3}">
           <p14:sldIdLst>
             <p14:sldId id="256"/>
           </p14:sldIdLst>
         </p14:section>
-        <p14:section name="The basics, no chess needed" id="{659b28ab-cb93-1255-2e52-9bb194e00127}">
+        <p14:section name="The basics, no chess needed" id="{74b8d4a2-ff82-bfd6-a5e1-fbda6addc769}">
           <p14:sldIdLst>
             <p14:sldId id="257"/>
             <p14:sldId id="258"/>
@@ -164,7 +164,7 @@
             <p14:sldId id="263"/>
           </p14:sldIdLst>
         </p14:section>
-        <p14:section name="What other researchers have found" id="{9f8785a4-f1d7-9ba6-e0f9-4ca37db19e8d}">
+        <p14:section name="What other researchers have found" id="{c322651f-1d0e-9eca-87dc-8ad444a71b8d}">
           <p14:sldIdLst>
             <p14:sldId id="264"/>
             <p14:sldId id="265"/>
@@ -180,13 +180,13 @@
             <p14:sldId id="275"/>
           </p14:sldIdLst>
         </p14:section>
-        <p14:section name="The questions" id="{f4cf7a17-23ba-5323-94bd-fc3f37caa358}">
+        <p14:section name="The questions" id="{efa24fbd-4a3e-d483-6329-8ad71ffda923}">
           <p14:sldIdLst>
             <p14:sldId id="276"/>
             <p14:sldId id="277"/>
           </p14:sldIdLst>
         </p14:section>
-        <p14:section name="How it was measured" id="{60711247-aeb8-854d-841f-6910fbc1294d}">
+        <p14:section name="How it was measured" id="{14f4b647-efe0-92e3-35fb-972953cce988}">
           <p14:sldIdLst>
             <p14:sldId id="278"/>
             <p14:sldId id="279"/>
@@ -200,7 +200,7 @@
             <p14:sldId id="287"/>
           </p14:sldIdLst>
         </p14:section>
-        <p14:section name="Results" id="{4e5b0b9a-802b-4ade-5eb8-21ea3afc77e6}">
+        <p14:section name="Results" id="{2f5ace50-b652-b5b5-5f5d-e43d3020df99}">
           <p14:sldIdLst>
             <p14:sldId id="288"/>
             <p14:sldId id="289"/>
@@ -209,18 +209,18 @@
             <p14:sldId id="292"/>
           </p14:sldIdLst>
         </p14:section>
-        <p14:section name="What it means" id="{3227e980-57a6-b102-5a9f-5089a9b7fb0b}">
+        <p14:section name="What it means" id="{ef7ab6a2-b2a1-5d85-a51a-a1f0e45c2146}">
           <p14:sldIdLst>
             <p14:sldId id="293"/>
             <p14:sldId id="294"/>
           </p14:sldIdLst>
         </p14:section>
-        <p14:section name="Conclusions" id="{6cb321e5-a00d-da11-4570-9304d964e8be}">
+        <p14:section name="Conclusions" id="{ebfa8b74-7825-cc56-d25d-84bc76a18932}">
           <p14:sldIdLst>
             <p14:sldId id="295"/>
           </p14:sldIdLst>
         </p14:section>
-        <p14:section name="Backup" id="{ce3fad35-9052-bc36-bbb0-d6a790739985}">
+        <p14:section name="Backup" id="{cef10102-f3d1-af2e-0784-238a430ec773}">
           <p14:sldIdLst>
             <p14:sldId id="296"/>
             <p14:sldId id="297"/>
@@ -1686,7 +1686,7 @@
           <a:p>
             <a:r>
               <a:rPr lang="en-US" dirty="0"/>
-              <a:t>Ken Regan is a computer scientist best known for detecting cheating in chess. This paper compares human and computer play using a very large set of positions, each run through four programs. Two findings matter for us. First, the size of a centipawn depends on the program: in 2014, Stockfish gave numbers about one and a half times bigger than the others. That is why our 72 centipawns cannot be compared with another study's numbers, and why every game in our study is scored with the same program and depth. Second, human mistakes grow when one side is far ahead, which is a reason not to judge a lucky win by the moves inside it, where the winner was losing badly. Their programs were 2014 versions, so the 1.5 figure is not known to hold for Stockfish 16.</a:t>
+              <a:t>A centipawn is not a fixed unit like a centimetre. Each chess program has its own scale, and even the same program gives different numbers at different search depths. Guid and Bratko found this when they graded world champions with four programs: the average error scores changed with the program and with the depth. Regan and colleagues measured how big the difference can be: in 2014, Stockfish's numbers were about one and a half times bigger than other programs'. Think of two bathroom scales that disagree. You can compare two people weighed on the same scale, but not someone weighed on one scale with someone weighed on the other. That is why our average of 72 centipawns cannot be compared with the 16.5 in Backus et al. It is also why our own comparison is fair: every lucky and deserved winner was weighed on the same scale, Stockfish 16 at depth 15. The 1.5 figure was for 2014 versions, so we only rely on the general point, not the exact number.</a:t>
             </a:r>
             <a:endParaRPr lang="en-US" dirty="0"/>
           </a:p>
@@ -10412,7 +10412,7 @@
                   <a:schemeClr val="tx2"/>
                 </a:solidFill>
               </a:rPr>
-              <a:t>Regan et al.: different chess programs score the same move differently</a:t>
+              <a:t>Scores depend on the program, so other papers' numbers can't be compared with ours</a:t>
             </a:r>
             <a:endParaRPr lang="en-US" sz="2600" dirty="0"/>
           </a:p>
@@ -10420,18 +10420,18 @@
       </p:sp>
       <p:sp>
         <p:nvSpPr>
-          <p:cNvPr id="3" name="What they asked"/>
+          <p:cNvPr id="3" name="Guid &amp; Bratko, on their 2011 study of average move errors with four programs"/>
           <p:cNvSpPr/>
           <p:nvPr/>
         </p:nvSpPr>
         <p:spPr>
           <a:xfrm>
-            <a:off x="457200" y="1115568"/>
-            <a:ext cx="1600200" cy="658368"/>
+            <a:off x="457200" y="1188720"/>
+            <a:ext cx="8229600" cy="914400"/>
           </a:xfrm>
           <a:prstGeom prst="roundRect">
             <a:avLst>
-              <a:gd name="adj" fmla="val 8333"/>
+              <a:gd name="adj" fmla="val 6000"/>
             </a:avLst>
           </a:prstGeom>
           <a:solidFill>
@@ -10453,8 +10453,8 @@
         </p:nvSpPr>
         <p:spPr>
           <a:xfrm>
-            <a:off x="548640" y="1115568"/>
-            <a:ext cx="1417320" cy="658368"/>
+            <a:off x="640080" y="1188720"/>
+            <a:ext cx="7863840" cy="914400"/>
           </a:xfrm>
           <a:prstGeom prst="rect">
             <a:avLst/>
@@ -10470,7 +10470,7 @@
               <a:buNone/>
             </a:pPr>
             <a:r>
-              <a:rPr lang="en-US" sz="1500" b="1" dirty="0">
+              <a:rPr lang="en-US" sz="1600" i="1" dirty="0">
                 <a:solidFill>
                   <a:srgbClr val="1F4E79"/>
                 </a:solidFill>
@@ -10478,65 +10478,43 @@
                 <a:ea typeface="Arial" pitchFamily="34" charset="-122"/>
                 <a:cs typeface="Arial" pitchFamily="34" charset="-120"/>
               </a:rPr>
-              <a:t>What they asked</a:t>
-            </a:r>
-            <a:endParaRPr lang="en-US" sz="1500" dirty="0"/>
-          </a:p>
-        </p:txBody>
-      </p:sp>
-      <p:sp>
-        <p:nvSpPr>
-          <p:cNvPr id="5" name="Text 3"/>
-          <p:cNvSpPr txBox="1"/>
-          <p:nvPr/>
-        </p:nvSpPr>
-        <p:spPr>
-          <a:xfrm>
-            <a:off x="2194560" y="1115568"/>
-            <a:ext cx="6492240" cy="658368"/>
-          </a:xfrm>
-          <a:prstGeom prst="rect">
-            <a:avLst/>
-          </a:prstGeom>
-          <a:noFill/>
-          <a:ln/>
-        </p:spPr>
-        <p:txBody>
-          <a:bodyPr wrap="square" lIns="0" tIns="0" rIns="0" bIns="0" rtlCol="0" anchor="ctr"/>
-          <a:lstStyle/>
+              <a:t>“… the scores are not invariable for the same program at different depths of search, the scores also differ significantly when using different programs.”</a:t>
+            </a:r>
+            <a:endParaRPr lang="en-US" sz="1600" dirty="0"/>
+          </a:p>
           <a:p>
             <a:pPr indent="0" marL="0">
               <a:buNone/>
             </a:pPr>
             <a:r>
-              <a:rPr lang="en-US" sz="1500" dirty="0">
-                <a:solidFill>
-                  <a:schemeClr val="tx1"/>
+              <a:rPr lang="en-US" sz="1300" dirty="0">
+                <a:solidFill>
+                  <a:srgbClr val="777777"/>
                 </a:solidFill>
                 <a:latin typeface="Arial" pitchFamily="34" charset="0"/>
                 <a:ea typeface="Arial" pitchFamily="34" charset="-122"/>
                 <a:cs typeface="Arial" pitchFamily="34" charset="-120"/>
               </a:rPr>
-              <a:t>How do the mistakes and choices of human players differ from those of computers?</a:t>
-            </a:r>
-            <a:endParaRPr lang="en-US" sz="1500" dirty="0"/>
-          </a:p>
-        </p:txBody>
-      </p:sp>
-      <p:sp>
-        <p:nvSpPr>
-          <p:cNvPr id="6" name="What they did"/>
+              <a:t>Guid &amp; Bratko, on their 2011 study of average move errors with four programs</a:t>
+            </a:r>
+            <a:endParaRPr lang="en-US" sz="1600" dirty="0"/>
+          </a:p>
+        </p:txBody>
+      </p:sp>
+      <p:sp>
+        <p:nvSpPr>
+          <p:cNvPr id="5" name="Regan, Biswas &amp; Zhou (2014), comparing four programs on 726,120 positions"/>
           <p:cNvSpPr/>
           <p:nvPr/>
         </p:nvSpPr>
         <p:spPr>
           <a:xfrm>
-            <a:off x="457200" y="1847088"/>
-            <a:ext cx="1600200" cy="1115568"/>
+            <a:off x="457200" y="2240280"/>
+            <a:ext cx="8229600" cy="914400"/>
           </a:xfrm>
           <a:prstGeom prst="roundRect">
             <a:avLst>
-              <a:gd name="adj" fmla="val 4918"/>
+              <a:gd name="adj" fmla="val 6000"/>
             </a:avLst>
           </a:prstGeom>
           <a:solidFill>
@@ -10552,14 +10530,14 @@
       </p:sp>
       <p:sp>
         <p:nvSpPr>
-          <p:cNvPr id="7" name="Text 5"/>
+          <p:cNvPr id="6" name="Text 4"/>
           <p:cNvSpPr txBox="1"/>
           <p:nvPr/>
         </p:nvSpPr>
         <p:spPr>
           <a:xfrm>
-            <a:off x="548640" y="1847088"/>
-            <a:ext cx="1417320" cy="1115568"/>
+            <a:off x="640080" y="2240280"/>
+            <a:ext cx="7863840" cy="914400"/>
           </a:xfrm>
           <a:prstGeom prst="rect">
             <a:avLst/>
@@ -10575,7 +10553,7 @@
               <a:buNone/>
             </a:pPr>
             <a:r>
-              <a:rPr lang="en-US" sz="1500" b="1" dirty="0">
+              <a:rPr lang="en-US" sz="1600" i="1" dirty="0">
                 <a:solidFill>
                   <a:srgbClr val="1F4E79"/>
                 </a:solidFill>
@@ -10583,170 +10561,43 @@
                 <a:ea typeface="Arial" pitchFamily="34" charset="-122"/>
                 <a:cs typeface="Arial" pitchFamily="34" charset="-120"/>
               </a:rPr>
-              <a:t>What they did</a:t>
-            </a:r>
-            <a:endParaRPr lang="en-US" sz="1500" dirty="0"/>
-          </a:p>
-        </p:txBody>
-      </p:sp>
-      <p:sp>
-        <p:nvSpPr>
-          <p:cNvPr id="8" name="Text 6"/>
-          <p:cNvSpPr txBox="1"/>
-          <p:nvPr/>
-        </p:nvSpPr>
-        <p:spPr>
-          <a:xfrm>
-            <a:off x="2194560" y="1847088"/>
-            <a:ext cx="6492240" cy="1115568"/>
-          </a:xfrm>
-          <a:prstGeom prst="rect">
-            <a:avLst/>
-          </a:prstGeom>
-          <a:noFill/>
-          <a:ln/>
-        </p:spPr>
-        <p:txBody>
-          <a:bodyPr wrap="square" lIns="0" tIns="0" rIns="0" bIns="0" rtlCol="0" anchor="ctr"/>
-          <a:lstStyle/>
+              <a:t>“… versions of Stockfish give values about 1.5 times higher magnitude than most programs …”</a:t>
+            </a:r>
+            <a:endParaRPr lang="en-US" sz="1600" dirty="0"/>
+          </a:p>
           <a:p>
             <a:pPr indent="0" marL="0">
               <a:buNone/>
             </a:pPr>
             <a:r>
-              <a:rPr lang="en-US" sz="1500" dirty="0">
-                <a:solidFill>
-                  <a:schemeClr val="tx1"/>
+              <a:rPr lang="en-US" sz="1300" dirty="0">
+                <a:solidFill>
+                  <a:srgbClr val="777777"/>
                 </a:solidFill>
                 <a:latin typeface="Arial" pitchFamily="34" charset="0"/>
                 <a:ea typeface="Arial" pitchFamily="34" charset="-122"/>
                 <a:cs typeface="Arial" pitchFamily="34" charset="-120"/>
               </a:rPr>
-              <a:t>726,120 positions from 208 top tournaments (2010 to 2012), each analysed by four different chess programs.</a:t>
-            </a:r>
-            <a:endParaRPr lang="en-US" sz="1500" dirty="0"/>
-          </a:p>
-        </p:txBody>
-      </p:sp>
-      <p:sp>
-        <p:nvSpPr>
-          <p:cNvPr id="9" name="What they found"/>
+              <a:t>Regan, Biswas &amp; Zhou (2014), comparing four programs on 726,120 positions</a:t>
+            </a:r>
+            <a:endParaRPr lang="en-US" sz="1600" dirty="0"/>
+          </a:p>
+        </p:txBody>
+      </p:sp>
+      <p:sp>
+        <p:nvSpPr>
+          <p:cNvPr id="7" name="so what"/>
           <p:cNvSpPr/>
           <p:nvPr/>
         </p:nvSpPr>
         <p:spPr>
           <a:xfrm>
-            <a:off x="457200" y="3035808"/>
-            <a:ext cx="1600200" cy="914400"/>
+            <a:off x="457200" y="3337560"/>
+            <a:ext cx="8229600" cy="1234440"/>
           </a:xfrm>
           <a:prstGeom prst="roundRect">
             <a:avLst>
-              <a:gd name="adj" fmla="val 6000"/>
-            </a:avLst>
-          </a:prstGeom>
-          <a:solidFill>
-            <a:srgbClr val="EBF3FA"/>
-          </a:solidFill>
-          <a:ln w="12700">
-            <a:solidFill>
-              <a:srgbClr val="2E75B6"/>
-            </a:solidFill>
-            <a:prstDash val="solid"/>
-          </a:ln>
-        </p:spPr>
-      </p:sp>
-      <p:sp>
-        <p:nvSpPr>
-          <p:cNvPr id="10" name="Text 8"/>
-          <p:cNvSpPr txBox="1"/>
-          <p:nvPr/>
-        </p:nvSpPr>
-        <p:spPr>
-          <a:xfrm>
-            <a:off x="548640" y="3035808"/>
-            <a:ext cx="1417320" cy="914400"/>
-          </a:xfrm>
-          <a:prstGeom prst="rect">
-            <a:avLst/>
-          </a:prstGeom>
-          <a:noFill/>
-          <a:ln/>
-        </p:spPr>
-        <p:txBody>
-          <a:bodyPr wrap="square" lIns="0" tIns="0" rIns="0" bIns="0" rtlCol="0" anchor="ctr"/>
-          <a:lstStyle/>
-          <a:p>
-            <a:pPr indent="0" marL="0">
-              <a:buNone/>
-            </a:pPr>
-            <a:r>
-              <a:rPr lang="en-US" sz="1500" b="1" dirty="0">
-                <a:solidFill>
-                  <a:srgbClr val="1F4E79"/>
-                </a:solidFill>
-                <a:latin typeface="Arial" pitchFamily="34" charset="0"/>
-                <a:ea typeface="Arial" pitchFamily="34" charset="-122"/>
-                <a:cs typeface="Arial" pitchFamily="34" charset="-120"/>
-              </a:rPr>
-              <a:t>What they found</a:t>
-            </a:r>
-            <a:endParaRPr lang="en-US" sz="1500" dirty="0"/>
-          </a:p>
-        </p:txBody>
-      </p:sp>
-      <p:sp>
-        <p:nvSpPr>
-          <p:cNvPr id="11" name="Text 9"/>
-          <p:cNvSpPr txBox="1"/>
-          <p:nvPr/>
-        </p:nvSpPr>
-        <p:spPr>
-          <a:xfrm>
-            <a:off x="2194560" y="3035808"/>
-            <a:ext cx="6492240" cy="914400"/>
-          </a:xfrm>
-          <a:prstGeom prst="rect">
-            <a:avLst/>
-          </a:prstGeom>
-          <a:noFill/>
-          <a:ln/>
-        </p:spPr>
-        <p:txBody>
-          <a:bodyPr wrap="square" lIns="0" tIns="0" rIns="0" bIns="0" rtlCol="0" anchor="ctr"/>
-          <a:lstStyle/>
-          <a:p>
-            <a:pPr indent="0" marL="0">
-              <a:buNone/>
-            </a:pPr>
-            <a:r>
-              <a:rPr lang="en-US" sz="1500" dirty="0">
-                <a:solidFill>
-                  <a:schemeClr val="tx1"/>
-                </a:solidFill>
-                <a:latin typeface="Arial" pitchFamily="34" charset="0"/>
-                <a:ea typeface="Arial" pitchFamily="34" charset="-122"/>
-                <a:cs typeface="Arial" pitchFamily="34" charset="-120"/>
-              </a:rPr>
-              <a:t>Humans err more the bigger either side's advantage, far more than computers do. A player's expected score is 2-3% lower when it is their turn to move. Stockfish's scores were about 1.5 times larger than other programs'.</a:t>
-            </a:r>
-            <a:endParaRPr lang="en-US" sz="1500" dirty="0"/>
-          </a:p>
-        </p:txBody>
-      </p:sp>
-      <p:sp>
-        <p:nvSpPr>
-          <p:cNvPr id="12" name="why it matters"/>
-          <p:cNvSpPr/>
-          <p:nvPr/>
-        </p:nvSpPr>
-        <p:spPr>
-          <a:xfrm>
-            <a:off x="457200" y="4041648"/>
-            <a:ext cx="8229600" cy="603504"/>
-          </a:xfrm>
-          <a:prstGeom prst="roundRect">
-            <a:avLst>
-              <a:gd name="adj" fmla="val 9091"/>
+              <a:gd name="adj" fmla="val 4444"/>
             </a:avLst>
           </a:prstGeom>
           <a:solidFill>
@@ -10762,14 +10613,14 @@
       </p:sp>
       <p:sp>
         <p:nvSpPr>
-          <p:cNvPr id="13" name="Text 11"/>
+          <p:cNvPr id="8" name="Text 6"/>
           <p:cNvSpPr txBox="1"/>
           <p:nvPr/>
         </p:nvSpPr>
         <p:spPr>
           <a:xfrm>
-            <a:off x="594360" y="4041648"/>
-            <a:ext cx="7955280" cy="603504"/>
+            <a:off x="594360" y="3337560"/>
+            <a:ext cx="7955280" cy="1234440"/>
           </a:xfrm>
           <a:prstGeom prst="rect">
             <a:avLst/>
@@ -10785,7 +10636,7 @@
               <a:buNone/>
             </a:pPr>
             <a:r>
-              <a:rPr lang="en-US" sz="1500" b="1" dirty="0">
+              <a:rPr lang="en-US" sz="1600" b="1" dirty="0">
                 <a:solidFill>
                   <a:srgbClr val="C27C0E"/>
                 </a:solidFill>
@@ -10793,13 +10644,13 @@
                 <a:ea typeface="Arial" pitchFamily="34" charset="-122"/>
                 <a:cs typeface="Arial" pitchFamily="34" charset="-120"/>
               </a:rPr>
-              <a:t>Why it matters for us: </a:t>
+              <a:t>So: </a:t>
             </a:r>
             <a:pPr indent="0" marL="0">
               <a:buNone/>
             </a:pPr>
             <a:r>
-              <a:rPr lang="en-US" sz="1500" dirty="0">
+              <a:rPr lang="en-US" sz="1600" dirty="0">
                 <a:solidFill>
                   <a:schemeClr val="tx1"/>
                 </a:solidFill>
@@ -10807,15 +10658,15 @@
                 <a:ea typeface="Arial" pitchFamily="34" charset="-122"/>
                 <a:cs typeface="Arial" pitchFamily="34" charset="-120"/>
               </a:rPr>
-              <a:t>a centipawn from one program is not a centipawn from another, so we only compare groups scored by one program at one setting.</a:t>
-            </a:r>
-            <a:endParaRPr lang="en-US" sz="1500" dirty="0"/>
-          </a:p>
-        </p:txBody>
-      </p:sp>
-      <p:sp>
-        <p:nvSpPr>
-          <p:cNvPr id="14" name="Text 12"/>
+              <a:t>our 72 cp per move cannot be set against Backus et al.'s 16.5, which used a different program on different players. What we can compare is lucky against deserved winners, because every game was scored by the same program (Stockfish 16) at the same depth.</a:t>
+            </a:r>
+            <a:endParaRPr lang="en-US" sz="1600" dirty="0"/>
+          </a:p>
+        </p:txBody>
+      </p:sp>
+      <p:sp>
+        <p:nvSpPr>
+          <p:cNvPr id="9" name="Text 7"/>
           <p:cNvSpPr txBox="1"/>
           <p:nvPr/>
         </p:nvSpPr>
@@ -10846,7 +10697,7 @@
                 <a:ea typeface="Arial" pitchFamily="34" charset="-122"/>
                 <a:cs typeface="Arial" pitchFamily="34" charset="-120"/>
               </a:rPr>
-              <a:t>Regan, Biswas &amp; Zhou (2014), AAAI-14 Workshop on Advances in Preference Handling</a:t>
+              <a:t>Guid &amp; Bratko (2011), ICGA Journal 34(2), via the authors' ChessBase summary; Regan et al. (2014)</a:t>
             </a:r>
             <a:endParaRPr lang="en-US" sz="1200" dirty="0"/>
           </a:p>
@@ -27338,6 +27189,26 @@
                 <a:cs typeface="Arial" pitchFamily="34" charset="-120"/>
               </a:rPr>
               <a:t>Kuenn, Seel &amp; Zegners (2020). Cognitive performance in the home office. IZA DP 13491; The Economic Journal, 132(643), 1218-1232 (2022).</a:t>
+            </a:r>
+            <a:endParaRPr lang="en-US" sz="1200" dirty="0"/>
+          </a:p>
+          <a:p>
+            <a:pPr indent="0" marL="0">
+              <a:spcAft>
+                <a:spcPts val="600"/>
+              </a:spcAft>
+              <a:buNone/>
+            </a:pPr>
+            <a:r>
+              <a:rPr lang="en-US" sz="1200" dirty="0">
+                <a:solidFill>
+                  <a:schemeClr val="tx1"/>
+                </a:solidFill>
+                <a:latin typeface="Arial" pitchFamily="34" charset="0"/>
+                <a:ea typeface="Arial" pitchFamily="34" charset="-122"/>
+                <a:cs typeface="Arial" pitchFamily="34" charset="-120"/>
+              </a:rPr>
+              <a:t>Guid &amp; Bratko (2011). Using heuristic-search based engines for estimating human skill at chess. ICGA Journal, 34(2), 71-81.</a:t>
             </a:r>
             <a:endParaRPr lang="en-US" sz="1200" dirty="0"/>
           </a:p>

</xml_diff>